<commit_message>
docs: update the deck's counts and the claims the new data changed
The matrix grew to 22 cells / 110 runs / 4 arms with the parents-only
selection arm, so slides 16, 25 and 28 restated a stale run count.

Slide 26's selection conclusion said only rank-based methods work. Two
measured sweeps since then falsify that: with the fitness offset removed
roulette reaches 0,96 and universal 0,97, and Boltzmann at Tc = 0,002
reaches 0,97 -- all with no elitism anywhere. The proportional family was
never broken by definition, only by the scale of the fitness function.

Slide 28 listed the Boltzmann miscalibration and the fitness rescaling as
future work. Both were done and measured, so they now read as results.

Text-only edits, applied by exact string replacement inside each slide's
XML so every byte outside the replaced runs is unchanged: 16 media parts
and all 176 package entries verified intact afterwards.
</commit_message>
<xml_diff>
--- a/TP2/docs/Presentacion.pptx
+++ b/TP2/docs/Presentacion.pptx
@@ -16744,7 +16744,7 @@
                 <a:cs typeface="Playfair Display"/>
                 <a:sym typeface="Playfair Display"/>
               </a:rPr>
-              <a:t>15</a:t>
+              <a:t>22</a:t>
             </a:r>
             <a:endParaRPr/>
           </a:p>
@@ -17068,7 +17068,7 @@
                 <a:cs typeface="Playfair Display"/>
                 <a:sym typeface="Playfair Display"/>
               </a:rPr>
-              <a:t>75</a:t>
+              <a:t>110</a:t>
             </a:r>
             <a:endParaRPr/>
           </a:p>
@@ -17392,7 +17392,7 @@
                 <a:cs typeface="Lato"/>
                 <a:sym typeface="Lato"/>
               </a:rPr>
-              <a:t>Tres brazos</a:t>
+              <a:t>Cuatro brazos</a:t>
             </a:r>
             <a:endParaRPr/>
           </a:p>
@@ -17419,7 +17419,7 @@
                 <a:cs typeface="Lato"/>
                 <a:sym typeface="Lato"/>
               </a:rPr>
-              <a:t>Selección (7 métodos) · supervivencia K/N (6 combinaciones) · control de cruza (2 celdas)</a:t>
+              <a:t>Selección (7 métodos, en padres y reemplazo) · selección solo en padres, reemplazo elite (7 métodos) · supervivencia K/N (6 combinaciones) · control de cruza (2 celdas)</a:t>
             </a:r>
             <a:endParaRPr/>
           </a:p>
@@ -22652,7 +22652,7 @@
                 <a:cs typeface="Lato"/>
                 <a:sym typeface="Lato"/>
               </a:rPr>
-              <a:t>Los dos retratos quedan fuera de la matriz formal de 75 corridas: son de dominio público, vía Wikimedia Commons, y están para variar la complejidad del objetivo.</a:t>
+              <a:t>Los dos retratos quedan fuera de la matriz formal de 110 corridas: son de dominio público, vía Wikimedia Commons, y están para variar la complejidad del objetivo.</a:t>
             </a:r>
             <a:endParaRPr/>
           </a:p>
@@ -23026,7 +23026,7 @@
                 <a:cs typeface="Lato"/>
                 <a:sym typeface="Lato"/>
               </a:rPr>
-              <a:t>Solo sirven los que desacoplan la probabilidad de la escala del fitness: ranking, elite y torneos. Ranking termina primero; elite llega más rápido.</a:t>
+              <a:t>Los basados en orden (ranking, elite, torneos) funcionan sobre el fitness crudo; ranking termina primero y elite llega más rápido. Los proporcionales no son peores: sirven igual una vez corregida la escala, y sin elitismo llegan a 0,96 reescalando y a 0,97 con Boltzmann a Tc = 0,002.</a:t>
             </a:r>
             <a:endParaRPr/>
           </a:p>
@@ -24616,7 +24616,7 @@
                 <a:cs typeface="Lato"/>
                 <a:sym typeface="Lato"/>
               </a:rPr>
-              <a:t>Las 75 corridas son todas sobre la bandera. Los otros objetivos quedaron fuera del diseño formal.</a:t>
+              <a:t>Las 110 corridas son todas sobre la bandera. Los otros objetivos quedaron fuera del diseño formal.</a:t>
             </a:r>
             <a:endParaRPr/>
           </a:p>
@@ -24725,7 +24725,7 @@
                 <a:cs typeface="Lato"/>
                 <a:sym typeface="Lato"/>
               </a:rPr>
-              <a:t>Boltzmann mal escalado</a:t>
+              <a:t>Boltzmann mal escalado — barrido y corregido</a:t>
             </a:r>
             <a:endParaRPr/>
           </a:p>
@@ -24752,7 +24752,7 @@
                 <a:cs typeface="Lato"/>
                 <a:sym typeface="Lato"/>
               </a:rPr>
-              <a:t>T0 = 5,0 y Tc = 0,5 son enormes frente a un spread de fitness de 0,14. Haría falta T del orden de 0,01.</a:t>
+              <a:t>T0 = 5,0 y Tc = 0,5 son enormes frente a un spread de fitness de 0,14. Barrimos T0, Tc y k sobre 110 corridas: Tc domina y las otras dos casi no pesan. Bajarla a 0,002 lleva Boltzmann de 0,72 a 0,97, sin elitismo.</a:t>
             </a:r>
             <a:endParaRPr/>
           </a:p>
@@ -24861,7 +24861,7 @@
                 <a:cs typeface="Lato"/>
                 <a:sym typeface="Lato"/>
               </a:rPr>
-              <a:t>Reescalar el fitness</a:t>
+              <a:t>Reescalar el fitness — implementado</a:t>
             </a:r>
             <a:endParaRPr/>
           </a:p>
@@ -24888,7 +24888,7 @@
                 <a:cs typeface="Lato"/>
                 <a:sym typeface="Lato"/>
               </a:rPr>
-              <a:t>Es el cambio de mayor impacto: recuperaría ruleta, universal y Boltzmann como métodos utilizables.</a:t>
+              <a:t>Confirmado: restarle el piso a la población recupera los tres. Sin elitismo, ruleta pasa de 0,72 a 0,96 y universal de 0,74 a 0,97. Queda como opción de configuración: el default sigue siendo la definición de la cátedra.</a:t>
             </a:r>
             <a:endParaRPr/>
           </a:p>

</xml_diff>

<commit_message>
docs: add the two result slides the new sweeps earned
Slide 18, "Selección: padres contra reemplazo", carries the parents-only
arm: the same 7 methods reach 0,973-0,986 once the method stops governing
replacement, which reframes the finding from "three methods are bad" to
"the replacement operator is what decides".

Slide 19, "Corregida la escala, funcionan los siete", carries the fitness
rescaling and the Tc sweep: roulette 0,72 -> 0,96, universal 0,74 -> 0,97,
Boltzmann 0,72 -> 0,97, none of them with elitism.

Both are clones of slide 17's own XML rather than new layout-built slides.
This deck places every shape by hand on the BLANK layout, so cloning is the
only way to inherit the design; only the text runs and the picture
relationship are substituted. Each figure's frame is recomputed to its own
aspect ratio inside slide 17's original box, centred -- measured distortion
is 0,00% on both. Slides 18-28 renumbered to 20-30 to match their new
position.
</commit_message>
<xml_diff>
--- a/TP2/docs/Presentacion.pptx
+++ b/TP2/docs/Presentacion.pptx
@@ -25,6 +25,8 @@
     <p:sldId id="270" r:id="rId21"/>
     <p:sldId id="271" r:id="rId22"/>
     <p:sldId id="272" r:id="rId23"/>
+    <p:sldId id="285" r:id="rId44"/>
+    <p:sldId id="286" r:id="rId45"/>
     <p:sldId id="273" r:id="rId24"/>
     <p:sldId id="274" r:id="rId25"/>
     <p:sldId id="275" r:id="rId26"/>
@@ -18360,7 +18362,7 @@
                 <a:cs typeface="Lato"/>
                 <a:sym typeface="Lato"/>
               </a:rPr>
-              <a:t>18</a:t>
+              <a:t>20</a:t>
             </a:r>
             <a:endParaRPr/>
           </a:p>
@@ -18897,7 +18899,7 @@
                 <a:cs typeface="Lato"/>
                 <a:sym typeface="Lato"/>
               </a:rPr>
-              <a:t>19</a:t>
+              <a:t>21</a:t>
             </a:r>
             <a:endParaRPr/>
           </a:p>
@@ -19530,7 +19532,7 @@
                 <a:cs typeface="Lato"/>
                 <a:sym typeface="Lato"/>
               </a:rPr>
-              <a:t>20</a:t>
+              <a:t>22</a:t>
             </a:r>
             <a:endParaRPr/>
           </a:p>
@@ -20067,7 +20069,7 @@
                 <a:cs typeface="Lato"/>
                 <a:sym typeface="Lato"/>
               </a:rPr>
-              <a:t>21</a:t>
+              <a:t>23</a:t>
             </a:r>
             <a:endParaRPr/>
           </a:p>
@@ -20438,7 +20440,7 @@
                 <a:cs typeface="Lato"/>
                 <a:sym typeface="Lato"/>
               </a:rPr>
-              <a:t>22</a:t>
+              <a:t>24</a:t>
             </a:r>
             <a:endParaRPr/>
           </a:p>
@@ -20975,7 +20977,7 @@
                 <a:cs typeface="Lato"/>
                 <a:sym typeface="Lato"/>
               </a:rPr>
-              <a:t>23</a:t>
+              <a:t>25</a:t>
             </a:r>
             <a:endParaRPr/>
           </a:p>
@@ -21512,7 +21514,7 @@
                 <a:cs typeface="Lato"/>
                 <a:sym typeface="Lato"/>
               </a:rPr>
-              <a:t>24</a:t>
+              <a:t>26</a:t>
             </a:r>
             <a:endParaRPr/>
           </a:p>
@@ -22079,7 +22081,7 @@
                 <a:cs typeface="Lato"/>
                 <a:sym typeface="Lato"/>
               </a:rPr>
-              <a:t>25</a:t>
+              <a:t>27</a:t>
             </a:r>
             <a:endParaRPr/>
           </a:p>
@@ -22784,7 +22786,7 @@
                 <a:cs typeface="Lato"/>
                 <a:sym typeface="Lato"/>
               </a:rPr>
-              <a:t>26</a:t>
+              <a:t>28</a:t>
             </a:r>
             <a:endParaRPr/>
           </a:p>
@@ -23566,7 +23568,7 @@
                 <a:cs typeface="Lato"/>
                 <a:sym typeface="Lato"/>
               </a:rPr>
-              <a:t>27</a:t>
+              <a:t>29</a:t>
             </a:r>
             <a:endParaRPr/>
           </a:p>
@@ -24374,7 +24376,7 @@
                 <a:cs typeface="Lato"/>
                 <a:sym typeface="Lato"/>
               </a:rPr>
-              <a:t>28</a:t>
+              <a:t>30</a:t>
             </a:r>
             <a:endParaRPr/>
           </a:p>
@@ -26038,6 +26040,1080 @@
                 <a:sym typeface="Lato"/>
               </a:rPr>
               <a:t>El orden no es cosmético: es lo que le da sentido a mutar un escalón de densidad en vez de saltar a un carácter arbitrario.</a:t>
+            </a:r>
+            <a:endParaRPr/>
+          </a:p>
+        </p:txBody>
+      </p:sp>
+    </p:spTree>
+  </p:cSld>
+  <p:clrMapOvr>
+    <a:masterClrMapping/>
+  </p:clrMapOvr>
+</p:sld>
+</file>
+
+<file path=ppt/slides/slide30.xml><?xml version="1.0" encoding="utf-8"?>
+<p:sld xmlns:a="http://schemas.openxmlformats.org/drawingml/2006/main" xmlns:r="http://schemas.openxmlformats.org/officeDocument/2006/relationships" xmlns:mc="http://schemas.openxmlformats.org/markup-compatibility/2006" xmlns:mv="urn:schemas-microsoft-com:mac:vml" xmlns:p="http://schemas.openxmlformats.org/presentationml/2006/main" xmlns:c="http://schemas.openxmlformats.org/drawingml/2006/chart" xmlns:dgm="http://schemas.openxmlformats.org/drawingml/2006/diagram" xmlns:o="urn:schemas-microsoft-com:office:office" xmlns:v="urn:schemas-microsoft-com:vml" xmlns:pvml="urn:schemas-microsoft-com:office:powerpoint" xmlns:com="http://schemas.openxmlformats.org/drawingml/2006/compatibility" xmlns:p14="http://schemas.microsoft.com/office/powerpoint/2010/main" xmlns:p15="http://schemas.microsoft.com/office/powerpoint/2012/main" xmlns:ahyp="http://schemas.microsoft.com/office/drawing/2018/hyperlinkcolor">
+  <p:cSld>
+    <p:spTree>
+      <p:nvGrpSpPr>
+        <p:cNvPr id="357" name="Shape 357"/>
+        <p:cNvGrpSpPr/>
+        <p:nvPr/>
+      </p:nvGrpSpPr>
+      <p:grpSpPr>
+        <a:xfrm>
+          <a:off x="0" y="0"/>
+          <a:ext cx="0" cy="0"/>
+          <a:chOff x="0" y="0"/>
+          <a:chExt cx="0" cy="0"/>
+        </a:xfrm>
+      </p:grpSpPr>
+      <p:sp>
+        <p:nvSpPr>
+          <p:cNvPr id="358" name="Google Shape;358;p29"/>
+          <p:cNvSpPr/>
+          <p:nvPr/>
+        </p:nvSpPr>
+        <p:spPr>
+          <a:xfrm>
+            <a:off x="0" y="5047488"/>
+            <a:ext cx="9144000" cy="100500"/>
+          </a:xfrm>
+          <a:prstGeom prst="rect">
+            <a:avLst/>
+          </a:prstGeom>
+          <a:solidFill>
+            <a:srgbClr val="F55E61"/>
+          </a:solidFill>
+          <a:ln>
+            <a:noFill/>
+          </a:ln>
+        </p:spPr>
+        <p:txBody>
+          <a:bodyPr anchorCtr="0" anchor="ctr" bIns="45700" lIns="91425" spcFirstLastPara="1" rIns="91425" wrap="square" tIns="45700">
+            <a:noAutofit/>
+          </a:bodyPr>
+          <a:lstStyle/>
+          <a:p>
+            <a:pPr indent="0" lvl="0" marL="0" marR="0" rtl="0" algn="ctr">
+              <a:lnSpc>
+                <a:spcPct val="100000"/>
+              </a:lnSpc>
+              <a:spcBef>
+                <a:spcPts val="0"/>
+              </a:spcBef>
+              <a:spcAft>
+                <a:spcPts val="0"/>
+              </a:spcAft>
+              <a:buNone/>
+            </a:pPr>
+            <a:r>
+              <a:t/>
+            </a:r>
+            <a:endParaRPr b="0" i="0" sz="1400" u="none" cap="none" strike="noStrike">
+              <a:solidFill>
+                <a:srgbClr val="000000"/>
+              </a:solidFill>
+              <a:latin typeface="Arial"/>
+              <a:ea typeface="Arial"/>
+              <a:cs typeface="Arial"/>
+              <a:sym typeface="Arial"/>
+            </a:endParaRPr>
+          </a:p>
+        </p:txBody>
+      </p:sp>
+      <p:sp>
+        <p:nvSpPr>
+          <p:cNvPr id="359" name="Google Shape;359;p29"/>
+          <p:cNvSpPr txBox="1"/>
+          <p:nvPr/>
+        </p:nvSpPr>
+        <p:spPr>
+          <a:xfrm>
+            <a:off x="7863840" y="4700016"/>
+            <a:ext cx="969300" cy="138600"/>
+          </a:xfrm>
+          <a:prstGeom prst="rect">
+            <a:avLst/>
+          </a:prstGeom>
+          <a:noFill/>
+          <a:ln>
+            <a:noFill/>
+          </a:ln>
+        </p:spPr>
+        <p:txBody>
+          <a:bodyPr anchorCtr="0" anchor="t" bIns="0" lIns="0" spcFirstLastPara="1" rIns="0" wrap="square" tIns="0">
+            <a:spAutoFit/>
+          </a:bodyPr>
+          <a:lstStyle/>
+          <a:p>
+            <a:pPr indent="0" lvl="0" marL="0" marR="0" rtl="0" algn="r">
+              <a:lnSpc>
+                <a:spcPct val="100000"/>
+              </a:lnSpc>
+              <a:spcBef>
+                <a:spcPts val="0"/>
+              </a:spcBef>
+              <a:spcAft>
+                <a:spcPts val="0"/>
+              </a:spcAft>
+              <a:buNone/>
+            </a:pPr>
+            <a:r>
+              <a:rPr b="0" i="0" lang="en-GB" sz="900" u="none" cap="none" strike="noStrike">
+                <a:solidFill>
+                  <a:srgbClr val="BFC7CA"/>
+                </a:solidFill>
+                <a:latin typeface="Lato"/>
+                <a:ea typeface="Lato"/>
+                <a:cs typeface="Lato"/>
+                <a:sym typeface="Lato"/>
+              </a:rPr>
+              <a:t>18</a:t>
+            </a:r>
+            <a:endParaRPr/>
+          </a:p>
+        </p:txBody>
+      </p:sp>
+      <p:sp>
+        <p:nvSpPr>
+          <p:cNvPr id="360" name="Google Shape;360;p29"/>
+          <p:cNvSpPr txBox="1"/>
+          <p:nvPr/>
+        </p:nvSpPr>
+        <p:spPr>
+          <a:xfrm>
+            <a:off x="310896" y="310896"/>
+            <a:ext cx="8522100" cy="400200"/>
+          </a:xfrm>
+          <a:prstGeom prst="rect">
+            <a:avLst/>
+          </a:prstGeom>
+          <a:noFill/>
+          <a:ln>
+            <a:noFill/>
+          </a:ln>
+        </p:spPr>
+        <p:txBody>
+          <a:bodyPr anchorCtr="0" anchor="t" bIns="0" lIns="0" spcFirstLastPara="1" rIns="0" wrap="square" tIns="0">
+            <a:spAutoFit/>
+          </a:bodyPr>
+          <a:lstStyle/>
+          <a:p>
+            <a:pPr indent="0" lvl="0" marL="0" marR="0" rtl="0" algn="l">
+              <a:lnSpc>
+                <a:spcPct val="100000"/>
+              </a:lnSpc>
+              <a:spcBef>
+                <a:spcPts val="0"/>
+              </a:spcBef>
+              <a:spcAft>
+                <a:spcPts val="0"/>
+              </a:spcAft>
+              <a:buNone/>
+            </a:pPr>
+            <a:r>
+              <a:rPr b="1" i="0" lang="en-GB" sz="2600" u="none" cap="none" strike="noStrike">
+                <a:solidFill>
+                  <a:srgbClr val="F55E61"/>
+                </a:solidFill>
+                <a:latin typeface="Playfair Display"/>
+                <a:ea typeface="Playfair Display"/>
+                <a:cs typeface="Playfair Display"/>
+                <a:sym typeface="Playfair Display"/>
+              </a:rPr>
+              <a:t>Selección: padres contra reemplazo</a:t>
+            </a:r>
+            <a:endParaRPr/>
+          </a:p>
+        </p:txBody>
+      </p:sp>
+      <p:sp>
+        <p:nvSpPr>
+          <p:cNvPr id="361" name="Google Shape;361;p29"/>
+          <p:cNvSpPr txBox="1"/>
+          <p:nvPr/>
+        </p:nvSpPr>
+        <p:spPr>
+          <a:xfrm>
+            <a:off x="310896" y="841248"/>
+            <a:ext cx="8522100" cy="169200"/>
+          </a:xfrm>
+          <a:prstGeom prst="rect">
+            <a:avLst/>
+          </a:prstGeom>
+          <a:noFill/>
+          <a:ln>
+            <a:noFill/>
+          </a:ln>
+        </p:spPr>
+        <p:txBody>
+          <a:bodyPr anchorCtr="0" anchor="t" bIns="0" lIns="0" spcFirstLastPara="1" rIns="0" wrap="square" tIns="0">
+            <a:spAutoFit/>
+          </a:bodyPr>
+          <a:lstStyle/>
+          <a:p>
+            <a:pPr indent="0" lvl="0" marL="0" marR="0" rtl="0" algn="l">
+              <a:lnSpc>
+                <a:spcPct val="100000"/>
+              </a:lnSpc>
+              <a:spcBef>
+                <a:spcPts val="0"/>
+              </a:spcBef>
+              <a:spcAft>
+                <a:spcPts val="0"/>
+              </a:spcAft>
+              <a:buNone/>
+            </a:pPr>
+            <a:r>
+              <a:rPr b="0" i="0" lang="en-GB" sz="1100" u="none" cap="none" strike="noStrike">
+                <a:solidFill>
+                  <a:srgbClr val="BFC7CA"/>
+                </a:solidFill>
+                <a:latin typeface="Lato"/>
+                <a:ea typeface="Lato"/>
+                <a:cs typeface="Lato"/>
+                <a:sym typeface="Lato"/>
+              </a:rPr>
+              <a:t>Ejercicio 2 · Resultados</a:t>
+            </a:r>
+            <a:endParaRPr/>
+          </a:p>
+        </p:txBody>
+      </p:sp>
+      <p:pic>
+        <p:nvPicPr>
+          <p:cNvPr descr="fig_seleccion.png" id="362" name="Google Shape;362;p29"/>
+          <p:cNvPicPr preferRelativeResize="0"/>
+          <p:nvPr/>
+        </p:nvPicPr>
+        <p:blipFill rotWithShape="1">
+          <a:blip r:embed="rId3">
+            <a:alphaModFix/>
+          </a:blip>
+          <a:srcRect b="0" l="0" r="0" t="0"/>
+          <a:stretch/>
+        </p:blipFill>
+        <p:spPr>
+          <a:xfrm>
+            <a:off x="829504" y="1207008"/>
+            <a:ext cx="4494905" cy="2946456"/>
+          </a:xfrm>
+          <a:prstGeom prst="rect">
+            <a:avLst/>
+          </a:prstGeom>
+          <a:noFill/>
+          <a:ln>
+            <a:noFill/>
+          </a:ln>
+        </p:spPr>
+      </p:pic>
+      <p:sp>
+        <p:nvSpPr>
+          <p:cNvPr id="363" name="Google Shape;363;p29"/>
+          <p:cNvSpPr/>
+          <p:nvPr/>
+        </p:nvSpPr>
+        <p:spPr>
+          <a:xfrm>
+            <a:off x="6053328" y="1207008"/>
+            <a:ext cx="2779800" cy="1417200"/>
+          </a:xfrm>
+          <a:prstGeom prst="roundRect">
+            <a:avLst>
+              <a:gd fmla="val 7000" name="adj"/>
+            </a:avLst>
+          </a:prstGeom>
+          <a:solidFill>
+            <a:srgbClr val="F2F4F5"/>
+          </a:solidFill>
+          <a:ln>
+            <a:noFill/>
+          </a:ln>
+        </p:spPr>
+        <p:txBody>
+          <a:bodyPr anchorCtr="0" anchor="ctr" bIns="45700" lIns="91425" spcFirstLastPara="1" rIns="91425" wrap="square" tIns="45700">
+            <a:noAutofit/>
+          </a:bodyPr>
+          <a:lstStyle/>
+          <a:p>
+            <a:pPr indent="0" lvl="0" marL="0" marR="0" rtl="0" algn="ctr">
+              <a:lnSpc>
+                <a:spcPct val="100000"/>
+              </a:lnSpc>
+              <a:spcBef>
+                <a:spcPts val="0"/>
+              </a:spcBef>
+              <a:spcAft>
+                <a:spcPts val="0"/>
+              </a:spcAft>
+              <a:buNone/>
+            </a:pPr>
+            <a:r>
+              <a:t/>
+            </a:r>
+            <a:endParaRPr b="0" i="0" sz="1400" u="none" cap="none" strike="noStrike">
+              <a:solidFill>
+                <a:srgbClr val="000000"/>
+              </a:solidFill>
+              <a:latin typeface="Arial"/>
+              <a:ea typeface="Arial"/>
+              <a:cs typeface="Arial"/>
+              <a:sym typeface="Arial"/>
+            </a:endParaRPr>
+          </a:p>
+        </p:txBody>
+      </p:sp>
+      <p:sp>
+        <p:nvSpPr>
+          <p:cNvPr id="364" name="Google Shape;364;p29"/>
+          <p:cNvSpPr txBox="1"/>
+          <p:nvPr/>
+        </p:nvSpPr>
+        <p:spPr>
+          <a:xfrm>
+            <a:off x="6199632" y="1353312"/>
+            <a:ext cx="2487300" cy="697800"/>
+          </a:xfrm>
+          <a:prstGeom prst="rect">
+            <a:avLst/>
+          </a:prstGeom>
+          <a:noFill/>
+          <a:ln>
+            <a:noFill/>
+          </a:ln>
+        </p:spPr>
+        <p:txBody>
+          <a:bodyPr anchorCtr="0" anchor="t" bIns="0" lIns="0" spcFirstLastPara="1" rIns="0" wrap="square" tIns="0">
+            <a:spAutoFit/>
+          </a:bodyPr>
+          <a:lstStyle/>
+          <a:p>
+            <a:pPr indent="0" lvl="0" marL="0" marR="0" rtl="0" algn="l">
+              <a:lnSpc>
+                <a:spcPct val="100000"/>
+              </a:lnSpc>
+              <a:spcBef>
+                <a:spcPts val="0"/>
+              </a:spcBef>
+              <a:spcAft>
+                <a:spcPts val="0"/>
+              </a:spcAft>
+              <a:buNone/>
+            </a:pPr>
+            <a:r>
+              <a:rPr b="1" i="0" lang="en-GB" sz="1050" u="none" cap="none" strike="noStrike">
+                <a:solidFill>
+                  <a:srgbClr val="F55E61"/>
+                </a:solidFill>
+                <a:latin typeface="Lato"/>
+                <a:ea typeface="Lato"/>
+                <a:cs typeface="Lato"/>
+                <a:sym typeface="Lato"/>
+              </a:rPr>
+              <a:t>El reemplazo es el que decide</a:t>
+            </a:r>
+            <a:endParaRPr/>
+          </a:p>
+          <a:p>
+            <a:pPr indent="0" lvl="0" marL="0" marR="0" rtl="0" algn="l">
+              <a:lnSpc>
+                <a:spcPct val="100000"/>
+              </a:lnSpc>
+              <a:spcBef>
+                <a:spcPts val="400"/>
+              </a:spcBef>
+              <a:spcAft>
+                <a:spcPts val="0"/>
+              </a:spcAft>
+              <a:buNone/>
+            </a:pPr>
+            <a:r>
+              <a:rPr b="0" i="0" lang="en-GB" sz="1050" u="none" cap="none" strike="noStrike">
+                <a:solidFill>
+                  <a:srgbClr val="5E696C"/>
+                </a:solidFill>
+                <a:latin typeface="Lato"/>
+                <a:ea typeface="Lato"/>
+                <a:cs typeface="Lato"/>
+                <a:sym typeface="Lato"/>
+              </a:rPr>
+              <a:t>Los mismos 7 métodos. Si el método gobierna padres y reemplazo, ruleta, universal y Boltzmann se quedan planos. Restringidos a la selección de padres, con reemplazo elite, los siete terminan entre 0,973 y 0,986.</a:t>
+            </a:r>
+            <a:endParaRPr/>
+          </a:p>
+        </p:txBody>
+      </p:sp>
+      <p:sp>
+        <p:nvSpPr>
+          <p:cNvPr id="365" name="Google Shape;365;p29"/>
+          <p:cNvSpPr/>
+          <p:nvPr/>
+        </p:nvSpPr>
+        <p:spPr>
+          <a:xfrm>
+            <a:off x="6053328" y="2743200"/>
+            <a:ext cx="2779800" cy="1417200"/>
+          </a:xfrm>
+          <a:prstGeom prst="roundRect">
+            <a:avLst>
+              <a:gd fmla="val 7000" name="adj"/>
+            </a:avLst>
+          </a:prstGeom>
+          <a:solidFill>
+            <a:srgbClr val="F2F4F5"/>
+          </a:solidFill>
+          <a:ln>
+            <a:noFill/>
+          </a:ln>
+        </p:spPr>
+        <p:txBody>
+          <a:bodyPr anchorCtr="0" anchor="ctr" bIns="45700" lIns="91425" spcFirstLastPara="1" rIns="91425" wrap="square" tIns="45700">
+            <a:noAutofit/>
+          </a:bodyPr>
+          <a:lstStyle/>
+          <a:p>
+            <a:pPr indent="0" lvl="0" marL="0" marR="0" rtl="0" algn="ctr">
+              <a:lnSpc>
+                <a:spcPct val="100000"/>
+              </a:lnSpc>
+              <a:spcBef>
+                <a:spcPts val="0"/>
+              </a:spcBef>
+              <a:spcAft>
+                <a:spcPts val="0"/>
+              </a:spcAft>
+              <a:buNone/>
+            </a:pPr>
+            <a:r>
+              <a:t/>
+            </a:r>
+            <a:endParaRPr b="0" i="0" sz="1400" u="none" cap="none" strike="noStrike">
+              <a:solidFill>
+                <a:srgbClr val="000000"/>
+              </a:solidFill>
+              <a:latin typeface="Arial"/>
+              <a:ea typeface="Arial"/>
+              <a:cs typeface="Arial"/>
+              <a:sym typeface="Arial"/>
+            </a:endParaRPr>
+          </a:p>
+        </p:txBody>
+      </p:sp>
+      <p:sp>
+        <p:nvSpPr>
+          <p:cNvPr id="366" name="Google Shape;366;p29"/>
+          <p:cNvSpPr txBox="1"/>
+          <p:nvPr/>
+        </p:nvSpPr>
+        <p:spPr>
+          <a:xfrm>
+            <a:off x="6199632" y="2889504"/>
+            <a:ext cx="2487300" cy="697800"/>
+          </a:xfrm>
+          <a:prstGeom prst="rect">
+            <a:avLst/>
+          </a:prstGeom>
+          <a:noFill/>
+          <a:ln>
+            <a:noFill/>
+          </a:ln>
+        </p:spPr>
+        <p:txBody>
+          <a:bodyPr anchorCtr="0" anchor="t" bIns="0" lIns="0" spcFirstLastPara="1" rIns="0" wrap="square" tIns="0">
+            <a:spAutoFit/>
+          </a:bodyPr>
+          <a:lstStyle/>
+          <a:p>
+            <a:pPr indent="0" lvl="0" marL="0" marR="0" rtl="0" algn="l">
+              <a:lnSpc>
+                <a:spcPct val="100000"/>
+              </a:lnSpc>
+              <a:spcBef>
+                <a:spcPts val="0"/>
+              </a:spcBef>
+              <a:spcAft>
+                <a:spcPts val="0"/>
+              </a:spcAft>
+              <a:buNone/>
+            </a:pPr>
+            <a:r>
+              <a:rPr b="1" i="0" lang="en-GB" sz="1050" u="none" cap="none" strike="noStrike">
+                <a:solidFill>
+                  <a:srgbClr val="F55E61"/>
+                </a:solidFill>
+                <a:latin typeface="Lato"/>
+                <a:ea typeface="Lato"/>
+                <a:cs typeface="Lato"/>
+                <a:sym typeface="Lato"/>
+              </a:rPr>
+              <a:t>Por qué</a:t>
+            </a:r>
+            <a:endParaRPr/>
+          </a:p>
+          <a:p>
+            <a:pPr indent="0" lvl="0" marL="0" marR="0" rtl="0" algn="l">
+              <a:lnSpc>
+                <a:spcPct val="100000"/>
+              </a:lnSpc>
+              <a:spcBef>
+                <a:spcPts val="400"/>
+              </a:spcBef>
+              <a:spcAft>
+                <a:spcPts val="0"/>
+              </a:spcAft>
+              <a:buNone/>
+            </a:pPr>
+            <a:r>
+              <a:rPr b="0" i="0" lang="en-GB" sz="1050" u="none" cap="none" strike="noStrike">
+                <a:solidFill>
+                  <a:srgbClr val="5E696C"/>
+                </a:solidFill>
+                <a:latin typeface="Lato"/>
+                <a:ea typeface="Lato"/>
+                <a:cs typeface="Lato"/>
+                <a:sym typeface="Lato"/>
+              </a:rPr>
+              <a:t>Un padre débil sólo cuesta velocidad: los buenos siguen en la población y se los puede volver a elegir. Un reemplazo débil los descarta. Con ruleta, el mejor individuo sobrevive 0,46 veces por generación.</a:t>
+            </a:r>
+            <a:endParaRPr/>
+          </a:p>
+        </p:txBody>
+      </p:sp>
+    </p:spTree>
+  </p:cSld>
+  <p:clrMapOvr>
+    <a:masterClrMapping/>
+  </p:clrMapOvr>
+</p:sld>
+</file>
+
+<file path=ppt/slides/slide31.xml><?xml version="1.0" encoding="utf-8"?>
+<p:sld xmlns:a="http://schemas.openxmlformats.org/drawingml/2006/main" xmlns:r="http://schemas.openxmlformats.org/officeDocument/2006/relationships" xmlns:mc="http://schemas.openxmlformats.org/markup-compatibility/2006" xmlns:mv="urn:schemas-microsoft-com:mac:vml" xmlns:p="http://schemas.openxmlformats.org/presentationml/2006/main" xmlns:c="http://schemas.openxmlformats.org/drawingml/2006/chart" xmlns:dgm="http://schemas.openxmlformats.org/drawingml/2006/diagram" xmlns:o="urn:schemas-microsoft-com:office:office" xmlns:v="urn:schemas-microsoft-com:vml" xmlns:pvml="urn:schemas-microsoft-com:office:powerpoint" xmlns:com="http://schemas.openxmlformats.org/drawingml/2006/compatibility" xmlns:p14="http://schemas.microsoft.com/office/powerpoint/2010/main" xmlns:p15="http://schemas.microsoft.com/office/powerpoint/2012/main" xmlns:ahyp="http://schemas.microsoft.com/office/drawing/2018/hyperlinkcolor">
+  <p:cSld>
+    <p:spTree>
+      <p:nvGrpSpPr>
+        <p:cNvPr id="357" name="Shape 357"/>
+        <p:cNvGrpSpPr/>
+        <p:nvPr/>
+      </p:nvGrpSpPr>
+      <p:grpSpPr>
+        <a:xfrm>
+          <a:off x="0" y="0"/>
+          <a:ext cx="0" cy="0"/>
+          <a:chOff x="0" y="0"/>
+          <a:chExt cx="0" cy="0"/>
+        </a:xfrm>
+      </p:grpSpPr>
+      <p:sp>
+        <p:nvSpPr>
+          <p:cNvPr id="358" name="Google Shape;358;p29"/>
+          <p:cNvSpPr/>
+          <p:nvPr/>
+        </p:nvSpPr>
+        <p:spPr>
+          <a:xfrm>
+            <a:off x="0" y="5047488"/>
+            <a:ext cx="9144000" cy="100500"/>
+          </a:xfrm>
+          <a:prstGeom prst="rect">
+            <a:avLst/>
+          </a:prstGeom>
+          <a:solidFill>
+            <a:srgbClr val="F55E61"/>
+          </a:solidFill>
+          <a:ln>
+            <a:noFill/>
+          </a:ln>
+        </p:spPr>
+        <p:txBody>
+          <a:bodyPr anchorCtr="0" anchor="ctr" bIns="45700" lIns="91425" spcFirstLastPara="1" rIns="91425" wrap="square" tIns="45700">
+            <a:noAutofit/>
+          </a:bodyPr>
+          <a:lstStyle/>
+          <a:p>
+            <a:pPr indent="0" lvl="0" marL="0" marR="0" rtl="0" algn="ctr">
+              <a:lnSpc>
+                <a:spcPct val="100000"/>
+              </a:lnSpc>
+              <a:spcBef>
+                <a:spcPts val="0"/>
+              </a:spcBef>
+              <a:spcAft>
+                <a:spcPts val="0"/>
+              </a:spcAft>
+              <a:buNone/>
+            </a:pPr>
+            <a:r>
+              <a:t/>
+            </a:r>
+            <a:endParaRPr b="0" i="0" sz="1400" u="none" cap="none" strike="noStrike">
+              <a:solidFill>
+                <a:srgbClr val="000000"/>
+              </a:solidFill>
+              <a:latin typeface="Arial"/>
+              <a:ea typeface="Arial"/>
+              <a:cs typeface="Arial"/>
+              <a:sym typeface="Arial"/>
+            </a:endParaRPr>
+          </a:p>
+        </p:txBody>
+      </p:sp>
+      <p:sp>
+        <p:nvSpPr>
+          <p:cNvPr id="359" name="Google Shape;359;p29"/>
+          <p:cNvSpPr txBox="1"/>
+          <p:nvPr/>
+        </p:nvSpPr>
+        <p:spPr>
+          <a:xfrm>
+            <a:off x="7863840" y="4700016"/>
+            <a:ext cx="969300" cy="138600"/>
+          </a:xfrm>
+          <a:prstGeom prst="rect">
+            <a:avLst/>
+          </a:prstGeom>
+          <a:noFill/>
+          <a:ln>
+            <a:noFill/>
+          </a:ln>
+        </p:spPr>
+        <p:txBody>
+          <a:bodyPr anchorCtr="0" anchor="t" bIns="0" lIns="0" spcFirstLastPara="1" rIns="0" wrap="square" tIns="0">
+            <a:spAutoFit/>
+          </a:bodyPr>
+          <a:lstStyle/>
+          <a:p>
+            <a:pPr indent="0" lvl="0" marL="0" marR="0" rtl="0" algn="r">
+              <a:lnSpc>
+                <a:spcPct val="100000"/>
+              </a:lnSpc>
+              <a:spcBef>
+                <a:spcPts val="0"/>
+              </a:spcBef>
+              <a:spcAft>
+                <a:spcPts val="0"/>
+              </a:spcAft>
+              <a:buNone/>
+            </a:pPr>
+            <a:r>
+              <a:rPr b="0" i="0" lang="en-GB" sz="900" u="none" cap="none" strike="noStrike">
+                <a:solidFill>
+                  <a:srgbClr val="BFC7CA"/>
+                </a:solidFill>
+                <a:latin typeface="Lato"/>
+                <a:ea typeface="Lato"/>
+                <a:cs typeface="Lato"/>
+                <a:sym typeface="Lato"/>
+              </a:rPr>
+              <a:t>19</a:t>
+            </a:r>
+            <a:endParaRPr/>
+          </a:p>
+        </p:txBody>
+      </p:sp>
+      <p:sp>
+        <p:nvSpPr>
+          <p:cNvPr id="360" name="Google Shape;360;p29"/>
+          <p:cNvSpPr txBox="1"/>
+          <p:nvPr/>
+        </p:nvSpPr>
+        <p:spPr>
+          <a:xfrm>
+            <a:off x="310896" y="310896"/>
+            <a:ext cx="8522100" cy="400200"/>
+          </a:xfrm>
+          <a:prstGeom prst="rect">
+            <a:avLst/>
+          </a:prstGeom>
+          <a:noFill/>
+          <a:ln>
+            <a:noFill/>
+          </a:ln>
+        </p:spPr>
+        <p:txBody>
+          <a:bodyPr anchorCtr="0" anchor="t" bIns="0" lIns="0" spcFirstLastPara="1" rIns="0" wrap="square" tIns="0">
+            <a:spAutoFit/>
+          </a:bodyPr>
+          <a:lstStyle/>
+          <a:p>
+            <a:pPr indent="0" lvl="0" marL="0" marR="0" rtl="0" algn="l">
+              <a:lnSpc>
+                <a:spcPct val="100000"/>
+              </a:lnSpc>
+              <a:spcBef>
+                <a:spcPts val="0"/>
+              </a:spcBef>
+              <a:spcAft>
+                <a:spcPts val="0"/>
+              </a:spcAft>
+              <a:buNone/>
+            </a:pPr>
+            <a:r>
+              <a:rPr b="1" i="0" lang="en-GB" sz="2600" u="none" cap="none" strike="noStrike">
+                <a:solidFill>
+                  <a:srgbClr val="F55E61"/>
+                </a:solidFill>
+                <a:latin typeface="Playfair Display"/>
+                <a:ea typeface="Playfair Display"/>
+                <a:cs typeface="Playfair Display"/>
+                <a:sym typeface="Playfair Display"/>
+              </a:rPr>
+              <a:t>Corregida la escala, funcionan los siete</a:t>
+            </a:r>
+            <a:endParaRPr/>
+          </a:p>
+        </p:txBody>
+      </p:sp>
+      <p:sp>
+        <p:nvSpPr>
+          <p:cNvPr id="361" name="Google Shape;361;p29"/>
+          <p:cNvSpPr txBox="1"/>
+          <p:nvPr/>
+        </p:nvSpPr>
+        <p:spPr>
+          <a:xfrm>
+            <a:off x="310896" y="841248"/>
+            <a:ext cx="8522100" cy="169200"/>
+          </a:xfrm>
+          <a:prstGeom prst="rect">
+            <a:avLst/>
+          </a:prstGeom>
+          <a:noFill/>
+          <a:ln>
+            <a:noFill/>
+          </a:ln>
+        </p:spPr>
+        <p:txBody>
+          <a:bodyPr anchorCtr="0" anchor="t" bIns="0" lIns="0" spcFirstLastPara="1" rIns="0" wrap="square" tIns="0">
+            <a:spAutoFit/>
+          </a:bodyPr>
+          <a:lstStyle/>
+          <a:p>
+            <a:pPr indent="0" lvl="0" marL="0" marR="0" rtl="0" algn="l">
+              <a:lnSpc>
+                <a:spcPct val="100000"/>
+              </a:lnSpc>
+              <a:spcBef>
+                <a:spcPts val="0"/>
+              </a:spcBef>
+              <a:spcAft>
+                <a:spcPts val="0"/>
+              </a:spcAft>
+              <a:buNone/>
+            </a:pPr>
+            <a:r>
+              <a:rPr b="0" i="0" lang="en-GB" sz="1100" u="none" cap="none" strike="noStrike">
+                <a:solidFill>
+                  <a:srgbClr val="BFC7CA"/>
+                </a:solidFill>
+                <a:latin typeface="Lato"/>
+                <a:ea typeface="Lato"/>
+                <a:cs typeface="Lato"/>
+                <a:sym typeface="Lato"/>
+              </a:rPr>
+              <a:t>Ejercicio 2 · Resultados</a:t>
+            </a:r>
+            <a:endParaRPr/>
+          </a:p>
+        </p:txBody>
+      </p:sp>
+      <p:pic>
+        <p:nvPicPr>
+          <p:cNvPr descr="fig_seleccion.png" id="362" name="Google Shape;362;p29"/>
+          <p:cNvPicPr preferRelativeResize="0"/>
+          <p:nvPr/>
+        </p:nvPicPr>
+        <p:blipFill rotWithShape="1">
+          <a:blip r:embed="rId3">
+            <a:alphaModFix/>
+          </a:blip>
+          <a:srcRect b="0" l="0" r="0" t="0"/>
+          <a:stretch/>
+        </p:blipFill>
+        <p:spPr>
+          <a:xfrm>
+            <a:off x="310896" y="1392033"/>
+            <a:ext cx="5532121" cy="2576406"/>
+          </a:xfrm>
+          <a:prstGeom prst="rect">
+            <a:avLst/>
+          </a:prstGeom>
+          <a:noFill/>
+          <a:ln>
+            <a:noFill/>
+          </a:ln>
+        </p:spPr>
+      </p:pic>
+      <p:sp>
+        <p:nvSpPr>
+          <p:cNvPr id="363" name="Google Shape;363;p29"/>
+          <p:cNvSpPr/>
+          <p:nvPr/>
+        </p:nvSpPr>
+        <p:spPr>
+          <a:xfrm>
+            <a:off x="6053328" y="1207008"/>
+            <a:ext cx="2779800" cy="1417200"/>
+          </a:xfrm>
+          <a:prstGeom prst="roundRect">
+            <a:avLst>
+              <a:gd fmla="val 7000" name="adj"/>
+            </a:avLst>
+          </a:prstGeom>
+          <a:solidFill>
+            <a:srgbClr val="F2F4F5"/>
+          </a:solidFill>
+          <a:ln>
+            <a:noFill/>
+          </a:ln>
+        </p:spPr>
+        <p:txBody>
+          <a:bodyPr anchorCtr="0" anchor="ctr" bIns="45700" lIns="91425" spcFirstLastPara="1" rIns="91425" wrap="square" tIns="45700">
+            <a:noAutofit/>
+          </a:bodyPr>
+          <a:lstStyle/>
+          <a:p>
+            <a:pPr indent="0" lvl="0" marL="0" marR="0" rtl="0" algn="ctr">
+              <a:lnSpc>
+                <a:spcPct val="100000"/>
+              </a:lnSpc>
+              <a:spcBef>
+                <a:spcPts val="0"/>
+              </a:spcBef>
+              <a:spcAft>
+                <a:spcPts val="0"/>
+              </a:spcAft>
+              <a:buNone/>
+            </a:pPr>
+            <a:r>
+              <a:t/>
+            </a:r>
+            <a:endParaRPr b="0" i="0" sz="1400" u="none" cap="none" strike="noStrike">
+              <a:solidFill>
+                <a:srgbClr val="000000"/>
+              </a:solidFill>
+              <a:latin typeface="Arial"/>
+              <a:ea typeface="Arial"/>
+              <a:cs typeface="Arial"/>
+              <a:sym typeface="Arial"/>
+            </a:endParaRPr>
+          </a:p>
+        </p:txBody>
+      </p:sp>
+      <p:sp>
+        <p:nvSpPr>
+          <p:cNvPr id="364" name="Google Shape;364;p29"/>
+          <p:cNvSpPr txBox="1"/>
+          <p:nvPr/>
+        </p:nvSpPr>
+        <p:spPr>
+          <a:xfrm>
+            <a:off x="6199632" y="1353312"/>
+            <a:ext cx="2487300" cy="697800"/>
+          </a:xfrm>
+          <a:prstGeom prst="rect">
+            <a:avLst/>
+          </a:prstGeom>
+          <a:noFill/>
+          <a:ln>
+            <a:noFill/>
+          </a:ln>
+        </p:spPr>
+        <p:txBody>
+          <a:bodyPr anchorCtr="0" anchor="t" bIns="0" lIns="0" spcFirstLastPara="1" rIns="0" wrap="square" tIns="0">
+            <a:spAutoFit/>
+          </a:bodyPr>
+          <a:lstStyle/>
+          <a:p>
+            <a:pPr indent="0" lvl="0" marL="0" marR="0" rtl="0" algn="l">
+              <a:lnSpc>
+                <a:spcPct val="100000"/>
+              </a:lnSpc>
+              <a:spcBef>
+                <a:spcPts val="0"/>
+              </a:spcBef>
+              <a:spcAft>
+                <a:spcPts val="0"/>
+              </a:spcAft>
+              <a:buNone/>
+            </a:pPr>
+            <a:r>
+              <a:rPr b="1" i="0" lang="en-GB" sz="1050" u="none" cap="none" strike="noStrike">
+                <a:solidFill>
+                  <a:srgbClr val="F55E61"/>
+                </a:solidFill>
+                <a:latin typeface="Lato"/>
+                <a:ea typeface="Lato"/>
+                <a:cs typeface="Lato"/>
+                <a:sym typeface="Lato"/>
+              </a:rPr>
+              <a:t>Reescalado y temperatura</a:t>
+            </a:r>
+            <a:endParaRPr/>
+          </a:p>
+          <a:p>
+            <a:pPr indent="0" lvl="0" marL="0" marR="0" rtl="0" algn="l">
+              <a:lnSpc>
+                <a:spcPct val="100000"/>
+              </a:lnSpc>
+              <a:spcBef>
+                <a:spcPts val="400"/>
+              </a:spcBef>
+              <a:spcAft>
+                <a:spcPts val="0"/>
+              </a:spcAft>
+              <a:buNone/>
+            </a:pPr>
+            <a:r>
+              <a:rPr b="0" i="0" lang="en-GB" sz="1050" u="none" cap="none" strike="noStrike">
+                <a:solidFill>
+                  <a:srgbClr val="5E696C"/>
+                </a:solidFill>
+                <a:latin typeface="Lato"/>
+                <a:ea typeface="Lato"/>
+                <a:cs typeface="Lato"/>
+                <a:sym typeface="Lato"/>
+              </a:rPr>
+              <a:t>Restarle a cada individuo el piso de la población: ruleta 0,72 → 0,96 y universal 0,74 → 0,97. Boltzmann con Tc = 0,002 en vez de 0,5: 0,72 → 0,97.</a:t>
+            </a:r>
+            <a:endParaRPr/>
+          </a:p>
+        </p:txBody>
+      </p:sp>
+      <p:sp>
+        <p:nvSpPr>
+          <p:cNvPr id="365" name="Google Shape;365;p29"/>
+          <p:cNvSpPr/>
+          <p:nvPr/>
+        </p:nvSpPr>
+        <p:spPr>
+          <a:xfrm>
+            <a:off x="6053328" y="2743200"/>
+            <a:ext cx="2779800" cy="1417200"/>
+          </a:xfrm>
+          <a:prstGeom prst="roundRect">
+            <a:avLst>
+              <a:gd fmla="val 7000" name="adj"/>
+            </a:avLst>
+          </a:prstGeom>
+          <a:solidFill>
+            <a:srgbClr val="F2F4F5"/>
+          </a:solidFill>
+          <a:ln>
+            <a:noFill/>
+          </a:ln>
+        </p:spPr>
+        <p:txBody>
+          <a:bodyPr anchorCtr="0" anchor="ctr" bIns="45700" lIns="91425" spcFirstLastPara="1" rIns="91425" wrap="square" tIns="45700">
+            <a:noAutofit/>
+          </a:bodyPr>
+          <a:lstStyle/>
+          <a:p>
+            <a:pPr indent="0" lvl="0" marL="0" marR="0" rtl="0" algn="ctr">
+              <a:lnSpc>
+                <a:spcPct val="100000"/>
+              </a:lnSpc>
+              <a:spcBef>
+                <a:spcPts val="0"/>
+              </a:spcBef>
+              <a:spcAft>
+                <a:spcPts val="0"/>
+              </a:spcAft>
+              <a:buNone/>
+            </a:pPr>
+            <a:r>
+              <a:t/>
+            </a:r>
+            <a:endParaRPr b="0" i="0" sz="1400" u="none" cap="none" strike="noStrike">
+              <a:solidFill>
+                <a:srgbClr val="000000"/>
+              </a:solidFill>
+              <a:latin typeface="Arial"/>
+              <a:ea typeface="Arial"/>
+              <a:cs typeface="Arial"/>
+              <a:sym typeface="Arial"/>
+            </a:endParaRPr>
+          </a:p>
+        </p:txBody>
+      </p:sp>
+      <p:sp>
+        <p:nvSpPr>
+          <p:cNvPr id="366" name="Google Shape;366;p29"/>
+          <p:cNvSpPr txBox="1"/>
+          <p:nvPr/>
+        </p:nvSpPr>
+        <p:spPr>
+          <a:xfrm>
+            <a:off x="6199632" y="2889504"/>
+            <a:ext cx="2487300" cy="697800"/>
+          </a:xfrm>
+          <a:prstGeom prst="rect">
+            <a:avLst/>
+          </a:prstGeom>
+          <a:noFill/>
+          <a:ln>
+            <a:noFill/>
+          </a:ln>
+        </p:spPr>
+        <p:txBody>
+          <a:bodyPr anchorCtr="0" anchor="t" bIns="0" lIns="0" spcFirstLastPara="1" rIns="0" wrap="square" tIns="0">
+            <a:spAutoFit/>
+          </a:bodyPr>
+          <a:lstStyle/>
+          <a:p>
+            <a:pPr indent="0" lvl="0" marL="0" marR="0" rtl="0" algn="l">
+              <a:lnSpc>
+                <a:spcPct val="100000"/>
+              </a:lnSpc>
+              <a:spcBef>
+                <a:spcPts val="0"/>
+              </a:spcBef>
+              <a:spcAft>
+                <a:spcPts val="0"/>
+              </a:spcAft>
+              <a:buNone/>
+            </a:pPr>
+            <a:r>
+              <a:rPr b="1" i="0" lang="en-GB" sz="1050" u="none" cap="none" strike="noStrike">
+                <a:solidFill>
+                  <a:srgbClr val="F55E61"/>
+                </a:solidFill>
+                <a:latin typeface="Lato"/>
+                <a:ea typeface="Lato"/>
+                <a:cs typeface="Lato"/>
+                <a:sym typeface="Lato"/>
+              </a:rPr>
+              <a:t>Sin elitismo en ninguno</a:t>
+            </a:r>
+            <a:endParaRPr/>
+          </a:p>
+          <a:p>
+            <a:pPr indent="0" lvl="0" marL="0" marR="0" rtl="0" algn="l">
+              <a:lnSpc>
+                <a:spcPct val="100000"/>
+              </a:lnSpc>
+              <a:spcBef>
+                <a:spcPts val="400"/>
+              </a:spcBef>
+              <a:spcAft>
+                <a:spcPts val="0"/>
+              </a:spcAft>
+              <a:buNone/>
+            </a:pPr>
+            <a:r>
+              <a:rPr b="0" i="0" lang="en-GB" sz="1050" u="none" cap="none" strike="noStrike">
+                <a:solidFill>
+                  <a:srgbClr val="5E696C"/>
+                </a:solidFill>
+                <a:latin typeface="Lato"/>
+                <a:ea typeface="Lato"/>
+                <a:cs typeface="Lato"/>
+                <a:sym typeface="Lato"/>
+              </a:rPr>
+              <a:t>Los tres métodos que la lámina anterior da por perdidos convergen igual que los otros cuatro. No fallaban por su definición, sino por la escala de la función de fitness.</a:t>
             </a:r>
             <a:endParaRPr/>
           </a:p>

</xml_diff>